<commit_message>
Update repository URL to https://github.com/vttrongsu1/csr-mooc3 across all reports and slides
</commit_message>
<xml_diff>
--- a/Data Science Capstone Project Report.pptx
+++ b/Data Science Capstone Project Report.pptx
@@ -3227,7 +3227,7 @@
             </a:r>
             <a:br/>
             <a:r>
-              <a:t>Project GitHub Repository: https://github.com/DataScientist/spacex-falcon9-capstone</a:t>
+              <a:t>Project GitHub Repository: https://github.com/vttrongsu1/csr-mooc3</a:t>
             </a:r>
           </a:p>
         </p:txBody>
@@ -3405,7 +3405,7 @@
               </a:defRPr>
             </a:pPr>
             <a:r>
-              <a:t>SpaceX Falcon 9 Capstone Project  |  IBM Applied Data Science Capstone  |  GitHub: https://github.com/DataScientist/spacex-falcon9-capstone</a:t>
+              <a:t>SpaceX Falcon 9 Capstone Project  |  IBM Applied Data Science Capstone  |  GitHub: https://github.com/vttrongsu1/csr-mooc3</a:t>
             </a:r>
           </a:p>
         </p:txBody>
@@ -3702,7 +3702,7 @@
               </a:defRPr>
             </a:pPr>
             <a:r>
-              <a:t>SpaceX Falcon 9 Capstone Project  |  IBM Applied Data Science Capstone  |  GitHub: https://github.com/DataScientist/spacex-falcon9-capstone</a:t>
+              <a:t>SpaceX Falcon 9 Capstone Project  |  IBM Applied Data Science Capstone  |  GitHub: https://github.com/vttrongsu1/csr-mooc3</a:t>
             </a:r>
           </a:p>
         </p:txBody>
@@ -4080,7 +4080,7 @@
               </a:defRPr>
             </a:pPr>
             <a:r>
-              <a:t>SpaceX Falcon 9 Capstone Project  |  IBM Applied Data Science Capstone  |  GitHub: https://github.com/DataScientist/spacex-falcon9-capstone</a:t>
+              <a:t>SpaceX Falcon 9 Capstone Project  |  IBM Applied Data Science Capstone  |  GitHub: https://github.com/vttrongsu1/csr-mooc3</a:t>
             </a:r>
           </a:p>
         </p:txBody>
@@ -4244,7 +4244,7 @@
               </a:defRPr>
             </a:pPr>
             <a:r>
-              <a:t>• GitHub URL: https://github.com/DataScientist/spacex-falcon9-capstone/blob/main/notebooks/04_EDA_with_SQL.ipynb</a:t>
+              <a:t>• GitHub URL: https://github.com/vttrongsu1/csr-mooc3/blob/main/notebooks/04_EDA_with_SQL.ipynb</a:t>
             </a:r>
           </a:p>
         </p:txBody>
@@ -4622,7 +4622,7 @@
               </a:defRPr>
             </a:pPr>
             <a:r>
-              <a:t>SpaceX Falcon 9 Capstone Project  |  IBM Applied Data Science Capstone  |  GitHub: https://github.com/DataScientist/spacex-falcon9-capstone</a:t>
+              <a:t>SpaceX Falcon 9 Capstone Project  |  IBM Applied Data Science Capstone  |  GitHub: https://github.com/vttrongsu1/csr-mooc3</a:t>
             </a:r>
           </a:p>
         </p:txBody>
@@ -5188,7 +5188,7 @@
               </a:defRPr>
             </a:pPr>
             <a:r>
-              <a:t>SpaceX Falcon 9 Capstone Project  |  IBM Applied Data Science Capstone  |  GitHub: https://github.com/DataScientist/spacex-falcon9-capstone</a:t>
+              <a:t>SpaceX Falcon 9 Capstone Project  |  IBM Applied Data Science Capstone  |  GitHub: https://github.com/vttrongsu1/csr-mooc3</a:t>
             </a:r>
           </a:p>
         </p:txBody>
@@ -5769,7 +5769,7 @@
               </a:defRPr>
             </a:pPr>
             <a:r>
-              <a:t>SpaceX Falcon 9 Capstone Project  |  IBM Applied Data Science Capstone  |  GitHub: https://github.com/DataScientist/spacex-falcon9-capstone</a:t>
+              <a:t>SpaceX Falcon 9 Capstone Project  |  IBM Applied Data Science Capstone  |  GitHub: https://github.com/vttrongsu1/csr-mooc3</a:t>
             </a:r>
           </a:p>
         </p:txBody>
@@ -5909,7 +5909,7 @@
               </a:defRPr>
             </a:pPr>
             <a:r>
-              <a:t>• GitHub URL: https://github.com/DataScientist/spacex-falcon9-capstone/blob/main/notebooks/06_Interactive_Visual_Analytics_Folium.ipynb</a:t>
+              <a:t>• GitHub URL: https://github.com/vttrongsu1/csr-mooc3/blob/main/notebooks/06_Interactive_Visual_Analytics_Folium.ipynb</a:t>
             </a:r>
           </a:p>
         </p:txBody>
@@ -6073,7 +6073,7 @@
               </a:defRPr>
             </a:pPr>
             <a:r>
-              <a:t>• GitHub URL: https://github.com/DataScientist/spacex-falcon9-capstone/blob/main/scripts/07_spacex_dash_app.py</a:t>
+              <a:t>• GitHub URL: https://github.com/vttrongsu1/csr-mooc3/blob/main/scripts/07_spacex_dash_app.py</a:t>
             </a:r>
           </a:p>
         </p:txBody>
@@ -6251,7 +6251,7 @@
               </a:defRPr>
             </a:pPr>
             <a:r>
-              <a:t>SpaceX Falcon 9 Capstone Project  |  IBM Applied Data Science Capstone  |  GitHub: https://github.com/DataScientist/spacex-falcon9-capstone</a:t>
+              <a:t>SpaceX Falcon 9 Capstone Project  |  IBM Applied Data Science Capstone  |  GitHub: https://github.com/vttrongsu1/csr-mooc3</a:t>
             </a:r>
           </a:p>
         </p:txBody>
@@ -6593,7 +6593,7 @@
               </a:defRPr>
             </a:pPr>
             <a:r>
-              <a:t>SpaceX Falcon 9 Capstone Project  |  IBM Applied Data Science Capstone  |  GitHub: https://github.com/DataScientist/spacex-falcon9-capstone</a:t>
+              <a:t>SpaceX Falcon 9 Capstone Project  |  IBM Applied Data Science Capstone  |  GitHub: https://github.com/vttrongsu1/csr-mooc3</a:t>
             </a:r>
           </a:p>
         </p:txBody>
@@ -6971,7 +6971,7 @@
               </a:defRPr>
             </a:pPr>
             <a:r>
-              <a:t>SpaceX Falcon 9 Capstone Project  |  IBM Applied Data Science Capstone  |  GitHub: https://github.com/DataScientist/spacex-falcon9-capstone</a:t>
+              <a:t>SpaceX Falcon 9 Capstone Project  |  IBM Applied Data Science Capstone  |  GitHub: https://github.com/vttrongsu1/csr-mooc3</a:t>
             </a:r>
           </a:p>
         </p:txBody>
@@ -7292,7 +7292,7 @@
               </a:defRPr>
             </a:pPr>
             <a:r>
-              <a:t>SpaceX Falcon 9 Capstone Project  |  IBM Applied Data Science Capstone  |  GitHub: https://github.com/DataScientist/spacex-falcon9-capstone</a:t>
+              <a:t>SpaceX Falcon 9 Capstone Project  |  IBM Applied Data Science Capstone  |  GitHub: https://github.com/vttrongsu1/csr-mooc3</a:t>
             </a:r>
           </a:p>
         </p:txBody>
@@ -7444,7 +7444,7 @@
               </a:defRPr>
             </a:pPr>
             <a:r>
-              <a:t>• GitHub URL: https://github.com/DataScientist/spacex-falcon9-capstone/blob/main/notebooks/08_Predictive_Analysis_Machine_Learning.ipynb</a:t>
+              <a:t>• GitHub URL: https://github.com/vttrongsu1/csr-mooc3/blob/main/notebooks/08_Predictive_Analysis_Machine_Learning.ipynb</a:t>
             </a:r>
           </a:p>
         </p:txBody>
@@ -7846,7 +7846,7 @@
               </a:defRPr>
             </a:pPr>
             <a:r>
-              <a:t>SpaceX Falcon 9 Capstone Project  |  IBM Applied Data Science Capstone  |  GitHub: https://github.com/DataScientist/spacex-falcon9-capstone</a:t>
+              <a:t>SpaceX Falcon 9 Capstone Project  |  IBM Applied Data Science Capstone  |  GitHub: https://github.com/vttrongsu1/csr-mooc3</a:t>
             </a:r>
           </a:p>
         </p:txBody>
@@ -8138,7 +8138,7 @@
               </a:defRPr>
             </a:pPr>
             <a:r>
-              <a:t>• Project Repository: https://github.com/DataScientist/spacex-falcon9-capstone</a:t>
+              <a:t>• Project Repository: https://github.com/vttrongsu1/csr-mooc3</a:t>
             </a:r>
           </a:p>
         </p:txBody>
@@ -8316,7 +8316,7 @@
               </a:defRPr>
             </a:pPr>
             <a:r>
-              <a:t>SpaceX Falcon 9 Capstone Project  |  IBM Applied Data Science Capstone  |  GitHub: https://github.com/DataScientist/spacex-falcon9-capstone</a:t>
+              <a:t>SpaceX Falcon 9 Capstone Project  |  IBM Applied Data Science Capstone  |  GitHub: https://github.com/vttrongsu1/csr-mooc3</a:t>
             </a:r>
           </a:p>
         </p:txBody>
@@ -8613,7 +8613,7 @@
               </a:defRPr>
             </a:pPr>
             <a:r>
-              <a:t>SpaceX Falcon 9 Capstone Project  |  IBM Applied Data Science Capstone  |  GitHub: https://github.com/DataScientist/spacex-falcon9-capstone</a:t>
+              <a:t>SpaceX Falcon 9 Capstone Project  |  IBM Applied Data Science Capstone  |  GitHub: https://github.com/vttrongsu1/csr-mooc3</a:t>
             </a:r>
           </a:p>
         </p:txBody>
@@ -8753,7 +8753,7 @@
               </a:defRPr>
             </a:pPr>
             <a:r>
-              <a:t>• Full Project Repository: https://github.com/DataScientist/spacex-falcon9-capstone</a:t>
+              <a:t>• Full Project Repository: https://github.com/vttrongsu1/csr-mooc3</a:t>
             </a:r>
           </a:p>
         </p:txBody>
@@ -9059,7 +9059,7 @@
               </a:defRPr>
             </a:pPr>
             <a:r>
-              <a:t>SpaceX Falcon 9 Capstone Project  |  IBM Applied Data Science Capstone  |  GitHub: https://github.com/DataScientist/spacex-falcon9-capstone</a:t>
+              <a:t>SpaceX Falcon 9 Capstone Project  |  IBM Applied Data Science Capstone  |  GitHub: https://github.com/vttrongsu1/csr-mooc3</a:t>
             </a:r>
           </a:p>
         </p:txBody>
@@ -9327,7 +9327,7 @@
               </a:defRPr>
             </a:pPr>
             <a:r>
-              <a:t>• Code &amp; Artifacts: https://github.com/DataScientist/spacex-falcon9-capstone</a:t>
+              <a:t>• Code &amp; Artifacts: https://github.com/vttrongsu1/csr-mooc3</a:t>
             </a:r>
           </a:p>
         </p:txBody>
@@ -9505,7 +9505,7 @@
               </a:defRPr>
             </a:pPr>
             <a:r>
-              <a:t>SpaceX Falcon 9 Capstone Project  |  IBM Applied Data Science Capstone  |  GitHub: https://github.com/DataScientist/spacex-falcon9-capstone</a:t>
+              <a:t>SpaceX Falcon 9 Capstone Project  |  IBM Applied Data Science Capstone  |  GitHub: https://github.com/vttrongsu1/csr-mooc3</a:t>
             </a:r>
           </a:p>
         </p:txBody>
@@ -9729,7 +9729,7 @@
               </a:defRPr>
             </a:pPr>
             <a:r>
-              <a:t>• GitHub URL: https://github.com/DataScientist/spacex-falcon9-capstone/blob/main/notebooks/01_Data_Collection_SpaceX_API.ipynb</a:t>
+              <a:t>• GitHub URL: https://github.com/vttrongsu1/csr-mooc3/blob/main/notebooks/01_Data_Collection_SpaceX_API.ipynb</a:t>
             </a:r>
           </a:p>
         </p:txBody>
@@ -10131,7 +10131,7 @@
               </a:defRPr>
             </a:pPr>
             <a:r>
-              <a:t>SpaceX Falcon 9 Capstone Project  |  IBM Applied Data Science Capstone  |  GitHub: https://github.com/DataScientist/spacex-falcon9-capstone</a:t>
+              <a:t>SpaceX Falcon 9 Capstone Project  |  IBM Applied Data Science Capstone  |  GitHub: https://github.com/vttrongsu1/csr-mooc3</a:t>
             </a:r>
           </a:p>
         </p:txBody>
@@ -10367,7 +10367,7 @@
               </a:defRPr>
             </a:pPr>
             <a:r>
-              <a:t>• GitHub URL: https://github.com/DataScientist/spacex-falcon9-capstone/blob/main/notebooks/02_Data_Collection_Web_Scraping.ipynb</a:t>
+              <a:t>• GitHub URL: https://github.com/vttrongsu1/csr-mooc3/blob/main/notebooks/02_Data_Collection_Web_Scraping.ipynb</a:t>
             </a:r>
           </a:p>
         </p:txBody>
@@ -10507,7 +10507,7 @@
               </a:defRPr>
             </a:pPr>
             <a:r>
-              <a:t>• Script Reference: https://github.com/DataScientist/spacex-falcon9-capstone/blob/main/scripts/02_data_collection_scraping.py</a:t>
+              <a:t>• Script Reference: https://github.com/vttrongsu1/csr-mooc3/blob/main/scripts/02_data_collection_scraping.py</a:t>
             </a:r>
           </a:p>
         </p:txBody>
@@ -10685,7 +10685,7 @@
               </a:defRPr>
             </a:pPr>
             <a:r>
-              <a:t>SpaceX Falcon 9 Capstone Project  |  IBM Applied Data Science Capstone  |  GitHub: https://github.com/DataScientist/spacex-falcon9-capstone</a:t>
+              <a:t>SpaceX Falcon 9 Capstone Project  |  IBM Applied Data Science Capstone  |  GitHub: https://github.com/vttrongsu1/csr-mooc3</a:t>
             </a:r>
           </a:p>
         </p:txBody>
@@ -11073,7 +11073,7 @@
               </a:defRPr>
             </a:pPr>
             <a:r>
-              <a:t>• GitHub URL: https://github.com/DataScientist/spacex-falcon9-capstone/blob/main/notebooks/03_Data_Wrangling.ipynb</a:t>
+              <a:t>• GitHub URL: https://github.com/vttrongsu1/csr-mooc3/blob/main/notebooks/03_Data_Wrangling.ipynb</a:t>
             </a:r>
           </a:p>
         </p:txBody>
@@ -11251,7 +11251,7 @@
               </a:defRPr>
             </a:pPr>
             <a:r>
-              <a:t>SpaceX Falcon 9 Capstone Project  |  IBM Applied Data Science Capstone  |  GitHub: https://github.com/DataScientist/spacex-falcon9-capstone</a:t>
+              <a:t>SpaceX Falcon 9 Capstone Project  |  IBM Applied Data Science Capstone  |  GitHub: https://github.com/vttrongsu1/csr-mooc3</a:t>
             </a:r>
           </a:p>
         </p:txBody>
@@ -11439,7 +11439,7 @@
               </a:defRPr>
             </a:pPr>
             <a:r>
-              <a:t>• GitHub URL: https://github.com/DataScientist/spacex-falcon9-capstone/blob/main/notebooks/05_EDA_with_Data_Visualization.ipynb</a:t>
+              <a:t>• GitHub URL: https://github.com/vttrongsu1/csr-mooc3/blob/main/notebooks/05_EDA_with_Data_Visualization.ipynb</a:t>
             </a:r>
           </a:p>
         </p:txBody>
@@ -11627,7 +11627,7 @@
               </a:defRPr>
             </a:pPr>
             <a:r>
-              <a:t>• Code Reference: https://github.com/DataScientist/spacex-falcon9-capstone/blob/main/scripts/05_eda_visualization.py</a:t>
+              <a:t>• Code Reference: https://github.com/vttrongsu1/csr-mooc3/blob/main/scripts/05_eda_visualization.py</a:t>
             </a:r>
           </a:p>
         </p:txBody>
@@ -11805,7 +11805,7 @@
               </a:defRPr>
             </a:pPr>
             <a:r>
-              <a:t>SpaceX Falcon 9 Capstone Project  |  IBM Applied Data Science Capstone  |  GitHub: https://github.com/DataScientist/spacex-falcon9-capstone</a:t>
+              <a:t>SpaceX Falcon 9 Capstone Project  |  IBM Applied Data Science Capstone  |  GitHub: https://github.com/vttrongsu1/csr-mooc3</a:t>
             </a:r>
           </a:p>
         </p:txBody>
@@ -12114,7 +12114,7 @@
               </a:defRPr>
             </a:pPr>
             <a:r>
-              <a:t>SpaceX Falcon 9 Capstone Project  |  IBM Applied Data Science Capstone  |  GitHub: https://github.com/DataScientist/spacex-falcon9-capstone</a:t>
+              <a:t>SpaceX Falcon 9 Capstone Project  |  IBM Applied Data Science Capstone  |  GitHub: https://github.com/vttrongsu1/csr-mooc3</a:t>
             </a:r>
           </a:p>
         </p:txBody>

</xml_diff>